<commit_message>
Fix rich-text line breaks not rendering on team/contact slide
pptxgenjs only honors breakLine/paraSpaceAfter when they're inside a run's
options object; three spots in build_deck.js had them as siblings of
options instead, so pptxgenjs silently dropped them and merged the runs
into one paragraph with no separators. Most visible on slide 16's contact
block: name, email, repo URL, and second name/email all ran together on
one line with no spaces between them. Fixed all three occurrences and
rebuilt the closing contact block per the founder's requested order:
Dayana Sanchez's name/email, the full repo URL, a blank line, then
Jacqueline Solano's name/email, each as its own line.

Co-Authored-By: Claude Sonnet 5 <noreply@anthropic.com>
Claude-Session: https://claude.ai/code/session_01VRnCZbLYbqC73tWmnG7XeQ
</commit_message>
<xml_diff>
--- a/docs/pitch/Acheron_Pitch_Deck.pptx
+++ b/docs/pitch/Acheron_Pitch_Deck.pptx
@@ -8425,24 +8425,27 @@
         </p:nvSpPr>
         <p:spPr>
           <a:xfrm>
-            <a:off x="640080" y="5623560"/>
-            <a:ext cx="7315200" cy="914400"/>
-          </a:xfrm>
-          <a:prstGeom prst="rect">
-            <a:avLst/>
-          </a:prstGeom>
-          <a:noFill/>
-          <a:ln/>
-        </p:spPr>
-        <p:txBody>
-          <a:bodyPr wrap="square" lIns="0" tIns="0" rIns="0" bIns="0" rtlCol="0" anchor="ctr"/>
-          <a:lstStyle/>
-          <a:p>
-            <a:pPr indent="0" marL="0">
-              <a:buNone/>
-            </a:pPr>
-            <a:r>
-              <a:rPr lang="en-US" sz="1400" b="1" dirty="0">
+            <a:off x="640080" y="5486400"/>
+            <a:ext cx="8686800" cy="1280160"/>
+          </a:xfrm>
+          <a:prstGeom prst="rect">
+            <a:avLst/>
+          </a:prstGeom>
+          <a:noFill/>
+          <a:ln/>
+        </p:spPr>
+        <p:txBody>
+          <a:bodyPr wrap="square" lIns="0" tIns="0" rIns="0" bIns="0" rtlCol="0" anchor="ctr"/>
+          <a:lstStyle/>
+          <a:p>
+            <a:pPr indent="0" marL="0">
+              <a:spcAft>
+                <a:spcPts val="400"/>
+              </a:spcAft>
+              <a:buNone/>
+            </a:pPr>
+            <a:r>
+              <a:rPr lang="en-US" sz="1300" b="1" dirty="0">
                 <a:solidFill>
                   <a:srgbClr val="FFFFFF"/>
                 </a:solidFill>
@@ -8450,37 +8453,66 @@
                 <a:ea typeface="Calibri" pitchFamily="34" charset="-122"/>
                 <a:cs typeface="Calibri" pitchFamily="34" charset="-120"/>
               </a:rPr>
-              <a:t>Dayana: sanchezleal1989@gmail.com</a:t>
-            </a:r>
-            <a:pPr indent="0" marL="0">
-              <a:buNone/>
-            </a:pPr>
-            <a:r>
-              <a:rPr lang="en-US" sz="1400" b="1" dirty="0">
-                <a:solidFill>
-                  <a:srgbClr val="FFFFFF"/>
+              <a:t>Dayana Sanchez: sanchezleal1989@gmail.com</a:t>
+            </a:r>
+            <a:endParaRPr lang="en-US" sz="1300" dirty="0"/>
+          </a:p>
+          <a:p>
+            <a:pPr indent="0" marL="0">
+              <a:spcAft>
+                <a:spcPts val="400"/>
+              </a:spcAft>
+              <a:buNone/>
+            </a:pPr>
+            <a:r>
+              <a:rPr lang="en-US" sz="1300" dirty="0">
+                <a:solidFill>
+                  <a:srgbClr val="AEC2C8"/>
                 </a:solidFill>
                 <a:latin typeface="Calibri" pitchFamily="34" charset="0"/>
                 <a:ea typeface="Calibri" pitchFamily="34" charset="-122"/>
                 <a:cs typeface="Calibri" pitchFamily="34" charset="-120"/>
               </a:rPr>
-              <a:t>Jacqueline: jackiea.solano@gmail.com</a:t>
-            </a:r>
-            <a:pPr indent="0" marL="0">
-              <a:buNone/>
-            </a:pPr>
-            <a:r>
-              <a:rPr lang="en-US" sz="1400" dirty="0">
-                <a:solidFill>
-                  <a:srgbClr val="AEC2C8"/>
+              <a:t>https://github.com/rewired89/Acheron.git</a:t>
+            </a:r>
+            <a:endParaRPr lang="en-US" sz="1300" dirty="0"/>
+          </a:p>
+          <a:p>
+            <a:pPr indent="0" marL="0">
+              <a:spcAft>
+                <a:spcPts val="400"/>
+              </a:spcAft>
+              <a:buNone/>
+            </a:pPr>
+            <a:r>
+              <a:rPr lang="en-US" sz="1300" dirty="0">
+                <a:solidFill>
+                  <a:srgbClr val="000000"/>
                 </a:solidFill>
                 <a:latin typeface="Calibri" pitchFamily="34" charset="0"/>
                 <a:ea typeface="Calibri" pitchFamily="34" charset="-122"/>
                 <a:cs typeface="Calibri" pitchFamily="34" charset="-120"/>
               </a:rPr>
-              <a:t>github.com/rewired89/Acheron</a:t>
-            </a:r>
-            <a:endParaRPr lang="en-US" sz="1400" dirty="0"/>
+              <a:t> </a:t>
+            </a:r>
+            <a:endParaRPr lang="en-US" sz="1300" dirty="0"/>
+          </a:p>
+          <a:p>
+            <a:pPr indent="0" marL="0">
+              <a:buNone/>
+            </a:pPr>
+            <a:r>
+              <a:rPr lang="en-US" sz="1300" b="1" dirty="0">
+                <a:solidFill>
+                  <a:srgbClr val="FFFFFF"/>
+                </a:solidFill>
+                <a:latin typeface="Calibri" pitchFamily="34" charset="0"/>
+                <a:ea typeface="Calibri" pitchFamily="34" charset="-122"/>
+                <a:cs typeface="Calibri" pitchFamily="34" charset="-120"/>
+              </a:rPr>
+              <a:t>Jacqueline Solano: jackiea.solano@gmail.com</a:t>
+            </a:r>
+            <a:endParaRPr lang="en-US" sz="1300" dirty="0"/>
           </a:p>
         </p:txBody>
       </p:sp>
@@ -11266,6 +11298,9 @@
               </a:rPr>
               <a:t> = photocopying the notebook.  </a:t>
             </a:r>
+            <a:endParaRPr lang="en-US" sz="1350" dirty="0"/>
+          </a:p>
+          <a:p>
             <a:pPr indent="0" marL="0">
               <a:lnSpc>
                 <a:spcPct val="130000"/>
@@ -12954,6 +12989,9 @@
               </a:rPr>
               <a:t>The real finding isn't that a matched circuit works (it does, 100% fidelity at 24 hours), it's what happens at severe promoter mismatch: </a:t>
             </a:r>
+            <a:endParaRPr lang="en-US" sz="1250" dirty="0"/>
+          </a:p>
+          <a:p>
             <a:pPr indent="0" marL="0">
               <a:lnSpc>
                 <a:spcPct val="120000"/>

</xml_diff>